<commit_message>
Update CKA analysis, report, figures, and docs with corrected depth-trend findings
</commit_message>
<xml_diff>
--- a/docs/Convergence_Defense.pptx
+++ b/docs/Convergence_Defense.pptx
@@ -2484,10 +2484,20 @@
           <a:lstStyle/>
           <a:p>
             <a:r>
-              <a:rPr lang="en-US" dirty="0"/>
               <a:t>If asked about the missed threshold: the pre-registered CKA diagonal target was &gt;0.5 and we measured 0.424. Reported as missed in Appendix C. The ratio criteria and stitching passed decisively.</a:t>
             </a:r>
-            <a:endParaRPr lang="en-US" dirty="0"/>
+          </a:p>
+          <a:p/>
+          <a:p>
+            <a:r>
+              <a:t>CKA panel wording (measured, A2-bis / report C.7): do NOT say 'hot diagonal' about the raw panel. DO say: the diagonal is elevated (ratio 1.20, permutation p &lt; 0.001) and rises strictly monotonically from layer 3 to layer 11, 0.125 to 0.742, Spearman rho = 1.000, p &lt; 1e-5 - which mirrors the stitching curve on this slide. Two independent measures agree on depth ordering.</a:t>
+            </a:r>
+          </a:p>
+          <a:p/>
+          <a:p>
+            <a:r>
+              <a:t>If asked why the panel looks blocky: hubness. Row means span 0.19 to 0.57 and 97% of the matrix energy is rank-1, so most cells reflect 'how similar is this layer to everything' rather than a specific pairing. Divide out the marginals and 77% of layers match within two, diagonal enriched at p = 0.006. Same anisotropy that defeated Procrustes in Experiment B.</a:t>
+            </a:r>
           </a:p>
         </p:txBody>
       </p:sp>

</xml_diff>